<commit_message>
Enrich deck with PR2 content (real-data pipeline, metrics, limits)
Add a 'Grounded in real Vietnamese data' slide (5 trips + sensors, YOLOv8,
3-panel replay, low/high modes, motorcycle behaviour calibration bridging to
APEX), an evaluation-metrics footnote on the results slide, and an honest-limits
line on the demo slide -- selected from Progress Report 2.

Co-Authored-By: Claude Opus 4.8 <noreply@anthropic.com>
</commit_message>
<xml_diff>
--- a/slides/Vietnam-MixedTrafficSim_APEX.pptx
+++ b/slides/Vietnam-MixedTrafficSim_APEX.pptx
@@ -13,6 +13,7 @@
     <p:sldId id="258" r:id="rId10"/>
     <p:sldId id="259" r:id="rId11"/>
     <p:sldId id="260" r:id="rId12"/>
+    <p:sldId id="261" r:id="rId13"/>
   </p:sldIdLst>
   <p:sldSz cx="12192000" cy="6858000"/>
   <p:notesSz cx="6858000" cy="9144000"/>
@@ -3411,7 +3412,7 @@
           <a:lstStyle/>
           <a:p>
             <a:r>
-              <a:t>APEX - predictive risk-aware planner</a:t>
+              <a:t>Grounded in real Vietnamese data (PR2)</a:t>
             </a:r>
           </a:p>
         </p:txBody>
@@ -3433,12 +3434,23 @@
           <a:p>
             <a:pPr/>
             <a:r>
-              <a:rPr sz="1800" b="1">
+              <a:rPr sz="1700" b="0">
                 <a:solidFill>
                   <a:srgbClr val="222222"/>
                 </a:solidFill>
               </a:rPr>
-              <a:t>Fuses car-following + reactive avoidance + sampling; fixes each one's flaw:</a:t>
+              <a:t>5 real car trips around VinUni / Ocean Park (QL5 corridor, roundabout, lakeside, residential, faculty parking).</a:t>
+            </a:r>
+          </a:p>
+          <a:p>
+            <a:pPr lvl="1"/>
+            <a:r>
+              <a:rPr sz="1600" b="0">
+                <a:solidFill>
+                  <a:srgbClr val="666666"/>
+                </a:solidFill>
+              </a:rPr>
+              <a:t>iPhone 12 Sensor Logger: video + GPS + IMU (100 Hz) + compass + barometer.</a:t>
             </a:r>
           </a:p>
           <a:p>
@@ -3449,7 +3461,7 @@
                   <a:srgbClr val="222222"/>
                 </a:solidFill>
               </a:rPr>
-              <a:t>Predict every motorcycle over a 4 s horizon + reachability envelope -&gt; anticipates a cut-in before it starts.</a:t>
+              <a:t>YOLOv8 detects car / motorcycle / pedestrian -&gt; actor counts (density), nearest range (TTC), class mix.</a:t>
             </a:r>
           </a:p>
           <a:p>
@@ -3460,7 +3472,7 @@
                   <a:srgbClr val="222222"/>
                 </a:solidFill>
               </a:rPr>
-              <a:t>Hard footprint-clearance margin to all motos over the whole horizon -&gt; collision-free by construction.</a:t>
+              <a:t>Synchronized 3-panel replay: GPS on the CommonRoad/Lanelet2 map | camera detections | drive stats.</a:t>
             </a:r>
           </a:p>
           <a:p>
@@ -3471,7 +3483,7 @@
                   <a:srgbClr val="222222"/>
                 </a:solidFill>
               </a:rPr>
-              <a:t>Junction-yield speed-cap for roadside / crossing motos -&gt; solves crossings (0/4).</a:t>
+              <a:t>Two demo modes from real density: low-traffic (&lt;=4 actors/frame) vs high-traffic (&gt;4).</a:t>
             </a:r>
           </a:p>
           <a:p>
@@ -3482,29 +3494,18 @@
                   <a:srgbClr val="222222"/>
                 </a:solidFill>
               </a:rPr>
-              <a:t>Multi-horizon trajectories -&gt; brake hard when needed, full speed when clear (no over-braking).</a:t>
-            </a:r>
-          </a:p>
-          <a:p>
-            <a:pPr/>
-            <a:r>
-              <a:rPr sz="1700" b="0">
-                <a:solidFill>
-                  <a:srgbClr val="222222"/>
+              <a:t>Motorcycle calibration: 4 behaviours (lane-splitting, cut-in, close-following, ambiguous priority)</a:t>
+            </a:r>
+          </a:p>
+          <a:p>
+            <a:pPr lvl="1"/>
+            <a:r>
+              <a:rPr sz="1600" b="1">
+                <a:solidFill>
+                  <a:srgbClr val="1E7A34"/>
                 </a:solidFill>
               </a:rPr>
-              <a:t>Speed-maximizing objective under the safety constraint -&gt; most efficient among safe planners.</a:t>
-            </a:r>
-          </a:p>
-          <a:p>
-            <a:pPr/>
-            <a:r>
-              <a:rPr sz="1700" b="1">
-                <a:solidFill>
-                  <a:srgbClr val="1E7A34"/>
-                </a:solidFill>
-              </a:rPr>
-              <a:t>Runs on the real VinUni CommonRoad map + recorded GPS.</a:t>
+              <a:t>-&gt; lateral velocity, acceleration, heading-change, gap -&gt; stochastic moto agents = APEX's occupancy-ellipse + dynamic safety cost.</a:t>
             </a:r>
           </a:p>
         </p:txBody>
@@ -3518,6 +3519,138 @@
 </file>
 
 <file path=ppt/slides/slide4.xml><?xml version="1.0" encoding="utf-8"?>
+<p:sld xmlns:a="http://schemas.openxmlformats.org/drawingml/2006/main" xmlns:p="http://schemas.openxmlformats.org/presentationml/2006/main" xmlns:r="http://schemas.openxmlformats.org/officeDocument/2006/relationships">
+  <p:cSld>
+    <p:spTree>
+      <p:nvGrpSpPr>
+        <p:cNvPr id="1" name=""/>
+        <p:cNvGrpSpPr/>
+        <p:nvPr/>
+      </p:nvGrpSpPr>
+      <p:grpSpPr/>
+      <p:sp>
+        <p:nvSpPr>
+          <p:cNvPr id="2" name="Title 1"/>
+          <p:cNvSpPr>
+            <a:spLocks noGrp="1"/>
+          </p:cNvSpPr>
+          <p:nvPr>
+            <p:ph type="title"/>
+          </p:nvPr>
+        </p:nvSpPr>
+        <p:spPr/>
+        <p:txBody>
+          <a:bodyPr/>
+          <a:lstStyle/>
+          <a:p>
+            <a:r>
+              <a:t>APEX - predictive risk-aware planner</a:t>
+            </a:r>
+          </a:p>
+        </p:txBody>
+      </p:sp>
+      <p:sp>
+        <p:nvSpPr>
+          <p:cNvPr id="3" name="Content Placeholder 2"/>
+          <p:cNvSpPr>
+            <a:spLocks noGrp="1"/>
+          </p:cNvSpPr>
+          <p:nvPr>
+            <p:ph idx="1"/>
+          </p:nvPr>
+        </p:nvSpPr>
+        <p:spPr/>
+        <p:txBody>
+          <a:bodyPr wrap="square"/>
+          <a:lstStyle/>
+          <a:p>
+            <a:pPr/>
+            <a:r>
+              <a:rPr sz="1800" b="1">
+                <a:solidFill>
+                  <a:srgbClr val="222222"/>
+                </a:solidFill>
+              </a:rPr>
+              <a:t>Fuses car-following + reactive avoidance + sampling; fixes each one's flaw:</a:t>
+            </a:r>
+          </a:p>
+          <a:p>
+            <a:pPr/>
+            <a:r>
+              <a:rPr sz="1700" b="0">
+                <a:solidFill>
+                  <a:srgbClr val="222222"/>
+                </a:solidFill>
+              </a:rPr>
+              <a:t>Predict every motorcycle over a 4 s horizon + reachability envelope -&gt; anticipates a cut-in before it starts.</a:t>
+            </a:r>
+          </a:p>
+          <a:p>
+            <a:pPr/>
+            <a:r>
+              <a:rPr sz="1700" b="0">
+                <a:solidFill>
+                  <a:srgbClr val="222222"/>
+                </a:solidFill>
+              </a:rPr>
+              <a:t>Hard footprint-clearance margin to all motos over the whole horizon -&gt; collision-free by construction.</a:t>
+            </a:r>
+          </a:p>
+          <a:p>
+            <a:pPr/>
+            <a:r>
+              <a:rPr sz="1700" b="0">
+                <a:solidFill>
+                  <a:srgbClr val="222222"/>
+                </a:solidFill>
+              </a:rPr>
+              <a:t>Junction-yield speed-cap for roadside / crossing motos -&gt; solves crossings (0/4).</a:t>
+            </a:r>
+          </a:p>
+          <a:p>
+            <a:pPr/>
+            <a:r>
+              <a:rPr sz="1700" b="0">
+                <a:solidFill>
+                  <a:srgbClr val="222222"/>
+                </a:solidFill>
+              </a:rPr>
+              <a:t>Multi-horizon trajectories -&gt; brake hard when needed, full speed when clear (no over-braking).</a:t>
+            </a:r>
+          </a:p>
+          <a:p>
+            <a:pPr/>
+            <a:r>
+              <a:rPr sz="1700" b="0">
+                <a:solidFill>
+                  <a:srgbClr val="222222"/>
+                </a:solidFill>
+              </a:rPr>
+              <a:t>Speed-maximizing objective under the safety constraint -&gt; most efficient among safe planners.</a:t>
+            </a:r>
+          </a:p>
+          <a:p>
+            <a:pPr/>
+            <a:r>
+              <a:rPr sz="1700" b="1">
+                <a:solidFill>
+                  <a:srgbClr val="1E7A34"/>
+                </a:solidFill>
+              </a:rPr>
+              <a:t>Runs on the real VinUni CommonRoad map + recorded GPS.</a:t>
+            </a:r>
+          </a:p>
+        </p:txBody>
+      </p:sp>
+    </p:spTree>
+  </p:cSld>
+  <p:clrMapOvr>
+    <a:masterClrMapping/>
+  </p:clrMapOvr>
+</p:sld>
+</file>
+
+<file path=ppt/slides/slide5.xml><?xml version="1.0" encoding="utf-8"?>
 <p:sld xmlns:a="http://schemas.openxmlformats.org/drawingml/2006/main" xmlns:p="http://schemas.openxmlformats.org/presentationml/2006/main" xmlns:r="http://schemas.openxmlformats.org/officeDocument/2006/relationships">
   <p:cSld>
     <p:spTree>
@@ -4260,6 +4393,17 @@
               <a:t>23% faster than the only other crash-free planner (R_T 1.43 vs 1.86); beats published IDM &amp; ORCA</a:t>
             </a:r>
           </a:p>
+          <a:p>
+            <a:pPr/>
+            <a:r>
+              <a:rPr sz="1300" b="0">
+                <a:solidFill>
+                  <a:srgbClr val="666666"/>
+                </a:solidFill>
+              </a:rPr>
+              <a:t>Metrics (PR2 Sec 6): collision = 0, min clearance &gt; 0.3 m, TTC exposure &lt; 2 s, AEB = 0, efficiency R_T &lt;= 1.25.</a:t>
+            </a:r>
+          </a:p>
         </p:txBody>
       </p:sp>
     </p:spTree>
@@ -4270,7 +4414,7 @@
 </p:sld>
 </file>
 
-<file path=ppt/slides/slide5.xml><?xml version="1.0" encoding="utf-8"?>
+<file path=ppt/slides/slide6.xml><?xml version="1.0" encoding="utf-8"?>
 <p:sld xmlns:a="http://schemas.openxmlformats.org/drawingml/2006/main" xmlns:p="http://schemas.openxmlformats.org/presentationml/2006/main" xmlns:r="http://schemas.openxmlformats.org/officeDocument/2006/relationships">
   <p:cSld>
     <p:spTree>
@@ -4346,6 +4490,17 @@
                 </a:solidFill>
               </a:rPr>
               <a:t>Aligns with the CommonRoad 2024 competition (winning Frenet paradigm; we add prediction it lacked).</a:t>
+            </a:r>
+          </a:p>
+          <a:p>
+            <a:pPr/>
+            <a:r>
+              <a:rPr sz="1600" b="0">
+                <a:solidFill>
+                  <a:srgbClr val="B21F1F"/>
+                </a:solidFill>
+              </a:rPr>
+              <a:t>Honest limits (PR2 Sec 7): motorcycle-behaviour calibration in progress; YOLO range is approximate.</a:t>
             </a:r>
           </a:p>
           <a:p>

</xml_diff>

<commit_message>
Add architecture + APEX model diagrams; embed in deck
- src/make_diagrams.py: render outputs/arch_pipeline.png (end-to-end system
  architecture) and outputs/apex_model.png (APEX planner model flow), light
  VinUni-red theme.
- make_pptx.py: add a System-architecture slide, switch the Method slide to the
  APEX model diagram, and embed a real 3-panel demo screenshot on the data
  slide. Deck is now 7 slides.

Co-Authored-By: Claude Opus 4.8 <noreply@anthropic.com>
</commit_message>
<xml_diff>
--- a/slides/Vietnam-MixedTrafficSim_APEX.pptx
+++ b/slides/Vietnam-MixedTrafficSim_APEX.pptx
@@ -14,6 +14,7 @@
     <p:sldId id="259" r:id="rId11"/>
     <p:sldId id="260" r:id="rId12"/>
     <p:sldId id="261" r:id="rId13"/>
+    <p:sldId id="262" r:id="rId14"/>
   </p:sldIdLst>
   <p:sldSz cx="12192000" cy="6858000"/>
   <p:notesSz cx="6858000" cy="9144000"/>
@@ -3412,104 +3413,35 @@
           <a:lstStyle/>
           <a:p>
             <a:r>
-              <a:t>Grounded in real Vietnamese data (PR2)</a:t>
+              <a:t>System architecture</a:t>
             </a:r>
           </a:p>
         </p:txBody>
       </p:sp>
-      <p:sp>
-        <p:nvSpPr>
-          <p:cNvPr id="3" name="Content Placeholder 2"/>
-          <p:cNvSpPr>
-            <a:spLocks noGrp="1"/>
-          </p:cNvSpPr>
-          <p:nvPr>
-            <p:ph idx="1"/>
-          </p:nvPr>
-        </p:nvSpPr>
-        <p:spPr/>
-        <p:txBody>
-          <a:bodyPr wrap="square"/>
-          <a:lstStyle/>
-          <a:p>
-            <a:pPr/>
-            <a:r>
-              <a:rPr sz="1700" b="0">
-                <a:solidFill>
-                  <a:srgbClr val="222222"/>
-                </a:solidFill>
-              </a:rPr>
-              <a:t>5 real car trips around VinUni / Ocean Park (QL5 corridor, roundabout, lakeside, residential, faculty parking).</a:t>
-            </a:r>
-          </a:p>
-          <a:p>
-            <a:pPr lvl="1"/>
-            <a:r>
-              <a:rPr sz="1600" b="0">
-                <a:solidFill>
-                  <a:srgbClr val="666666"/>
-                </a:solidFill>
-              </a:rPr>
-              <a:t>iPhone 12 Sensor Logger: video + GPS + IMU (100 Hz) + compass + barometer.</a:t>
-            </a:r>
-          </a:p>
-          <a:p>
-            <a:pPr/>
-            <a:r>
-              <a:rPr sz="1700" b="0">
-                <a:solidFill>
-                  <a:srgbClr val="222222"/>
-                </a:solidFill>
-              </a:rPr>
-              <a:t>YOLOv8 detects car / motorcycle / pedestrian -&gt; actor counts (density), nearest range (TTC), class mix.</a:t>
-            </a:r>
-          </a:p>
-          <a:p>
-            <a:pPr/>
-            <a:r>
-              <a:rPr sz="1700" b="0">
-                <a:solidFill>
-                  <a:srgbClr val="222222"/>
-                </a:solidFill>
-              </a:rPr>
-              <a:t>Synchronized 3-panel replay: GPS on the CommonRoad/Lanelet2 map | camera detections | drive stats.</a:t>
-            </a:r>
-          </a:p>
-          <a:p>
-            <a:pPr/>
-            <a:r>
-              <a:rPr sz="1700" b="0">
-                <a:solidFill>
-                  <a:srgbClr val="222222"/>
-                </a:solidFill>
-              </a:rPr>
-              <a:t>Two demo modes from real density: low-traffic (&lt;=4 actors/frame) vs high-traffic (&gt;4).</a:t>
-            </a:r>
-          </a:p>
-          <a:p>
-            <a:pPr/>
-            <a:r>
-              <a:rPr sz="1700" b="0">
-                <a:solidFill>
-                  <a:srgbClr val="222222"/>
-                </a:solidFill>
-              </a:rPr>
-              <a:t>Motorcycle calibration: 4 behaviours (lane-splitting, cut-in, close-following, ambiguous priority)</a:t>
-            </a:r>
-          </a:p>
-          <a:p>
-            <a:pPr lvl="1"/>
-            <a:r>
-              <a:rPr sz="1600" b="1">
-                <a:solidFill>
-                  <a:srgbClr val="1E7A34"/>
-                </a:solidFill>
-              </a:rPr>
-              <a:t>-&gt; lateral velocity, acceleration, heading-change, gap -&gt; stochastic moto agents = APEX's occupancy-ellipse + dynamic safety cost.</a:t>
-            </a:r>
-          </a:p>
-        </p:txBody>
-      </p:sp>
+      <p:pic>
+        <p:nvPicPr>
+          <p:cNvPr id="3" name="Picture 2" descr="arch_pipeline.png"/>
+          <p:cNvPicPr>
+            <a:picLocks noChangeAspect="1"/>
+          </p:cNvPicPr>
+          <p:nvPr/>
+        </p:nvPicPr>
+        <p:blipFill>
+          <a:blip r:embed="rId2"/>
+          <a:stretch>
+            <a:fillRect/>
+          </a:stretch>
+        </p:blipFill>
+        <p:spPr>
+          <a:xfrm>
+            <a:off x="411480" y="1325880"/>
+            <a:ext cx="11338560" cy="4960620"/>
+          </a:xfrm>
+          <a:prstGeom prst="rect">
+            <a:avLst/>
+          </a:prstGeom>
+        </p:spPr>
+      </p:pic>
     </p:spTree>
   </p:cSld>
   <p:clrMapOvr>
@@ -3544,7 +3476,7 @@
           <a:lstStyle/>
           <a:p>
             <a:r>
-              <a:t>APEX - predictive risk-aware planner</a:t>
+              <a:t>Grounded in real Vietnamese data (PR2)</a:t>
             </a:r>
           </a:p>
         </p:txBody>
@@ -3566,12 +3498,23 @@
           <a:p>
             <a:pPr/>
             <a:r>
-              <a:rPr sz="1800" b="1">
+              <a:rPr sz="1700" b="0">
                 <a:solidFill>
                   <a:srgbClr val="222222"/>
                 </a:solidFill>
               </a:rPr>
-              <a:t>Fuses car-following + reactive avoidance + sampling; fixes each one's flaw:</a:t>
+              <a:t>5 real car trips around VinUni / Ocean Park (QL5 corridor, roundabout, lakeside, residential, faculty parking).</a:t>
+            </a:r>
+          </a:p>
+          <a:p>
+            <a:pPr lvl="1"/>
+            <a:r>
+              <a:rPr sz="1600" b="0">
+                <a:solidFill>
+                  <a:srgbClr val="666666"/>
+                </a:solidFill>
+              </a:rPr>
+              <a:t>iPhone 12 Sensor Logger: video + GPS + IMU (100 Hz) + compass + barometer.</a:t>
             </a:r>
           </a:p>
           <a:p>
@@ -3582,7 +3525,7 @@
                   <a:srgbClr val="222222"/>
                 </a:solidFill>
               </a:rPr>
-              <a:t>Predict every motorcycle over a 4 s horizon + reachability envelope -&gt; anticipates a cut-in before it starts.</a:t>
+              <a:t>YOLOv8 detects car / motorcycle / pedestrian -&gt; actor counts (density), nearest range (TTC), class mix.</a:t>
             </a:r>
           </a:p>
           <a:p>
@@ -3593,7 +3536,7 @@
                   <a:srgbClr val="222222"/>
                 </a:solidFill>
               </a:rPr>
-              <a:t>Hard footprint-clearance margin to all motos over the whole horizon -&gt; collision-free by construction.</a:t>
+              <a:t>Synchronized 3-panel replay: GPS on the CommonRoad/Lanelet2 map | camera detections | drive stats.</a:t>
             </a:r>
           </a:p>
           <a:p>
@@ -3604,7 +3547,7 @@
                   <a:srgbClr val="222222"/>
                 </a:solidFill>
               </a:rPr>
-              <a:t>Junction-yield speed-cap for roadside / crossing motos -&gt; solves crossings (0/4).</a:t>
+              <a:t>Two demo modes from real density: low-traffic (&lt;=4 actors/frame) vs high-traffic (&gt;4).</a:t>
             </a:r>
           </a:p>
           <a:p>
@@ -3615,29 +3558,139 @@
                   <a:srgbClr val="222222"/>
                 </a:solidFill>
               </a:rPr>
-              <a:t>Multi-horizon trajectories -&gt; brake hard when needed, full speed when clear (no over-braking).</a:t>
-            </a:r>
-          </a:p>
+              <a:t>Motorcycle calibration: 4 behaviours (lane-splitting, cut-in, close-following, ambiguous priority)</a:t>
+            </a:r>
+          </a:p>
+          <a:p>
+            <a:pPr lvl="1"/>
+            <a:r>
+              <a:rPr sz="1600" b="1">
+                <a:solidFill>
+                  <a:srgbClr val="1E7A34"/>
+                </a:solidFill>
+              </a:rPr>
+              <a:t>-&gt; lateral velocity, acceleration, heading-change, gap -&gt; stochastic moto agents = APEX's occupancy-ellipse + dynamic safety cost.</a:t>
+            </a:r>
+          </a:p>
+        </p:txBody>
+      </p:sp>
+      <p:pic>
+        <p:nvPicPr>
+          <p:cNvPr id="4" name="Picture 3" descr="Quang Vu - Vinuni - Robotic - Vietnam Mixed Trafficsim - Real time sync driving trip [ADWuhLiD450 - 2056x514 - 0m56s].png"/>
+          <p:cNvPicPr>
+            <a:picLocks noChangeAspect="1"/>
+          </p:cNvPicPr>
+          <p:nvPr/>
+        </p:nvPicPr>
+        <p:blipFill>
+          <a:blip r:embed="rId2"/>
+          <a:stretch>
+            <a:fillRect/>
+          </a:stretch>
+        </p:blipFill>
+        <p:spPr>
+          <a:xfrm>
+            <a:off x="2560320" y="5120640"/>
+            <a:ext cx="7040880" cy="1760220"/>
+          </a:xfrm>
+          <a:prstGeom prst="rect">
+            <a:avLst/>
+          </a:prstGeom>
+        </p:spPr>
+      </p:pic>
+    </p:spTree>
+  </p:cSld>
+  <p:clrMapOvr>
+    <a:masterClrMapping/>
+  </p:clrMapOvr>
+</p:sld>
+</file>
+
+<file path=ppt/slides/slide5.xml><?xml version="1.0" encoding="utf-8"?>
+<p:sld xmlns:a="http://schemas.openxmlformats.org/drawingml/2006/main" xmlns:p="http://schemas.openxmlformats.org/presentationml/2006/main" xmlns:r="http://schemas.openxmlformats.org/officeDocument/2006/relationships">
+  <p:cSld>
+    <p:spTree>
+      <p:nvGrpSpPr>
+        <p:cNvPr id="1" name=""/>
+        <p:cNvGrpSpPr/>
+        <p:nvPr/>
+      </p:nvGrpSpPr>
+      <p:grpSpPr/>
+      <p:sp>
+        <p:nvSpPr>
+          <p:cNvPr id="2" name="Title 1"/>
+          <p:cNvSpPr>
+            <a:spLocks noGrp="1"/>
+          </p:cNvSpPr>
+          <p:nvPr>
+            <p:ph type="title"/>
+          </p:nvPr>
+        </p:nvSpPr>
+        <p:spPr/>
+        <p:txBody>
+          <a:bodyPr/>
+          <a:lstStyle/>
+          <a:p>
+            <a:r>
+              <a:t>APEX - predictive risk-aware planner</a:t>
+            </a:r>
+          </a:p>
+        </p:txBody>
+      </p:sp>
+      <p:pic>
+        <p:nvPicPr>
+          <p:cNvPr id="3" name="Picture 2" descr="apex_model.png"/>
+          <p:cNvPicPr>
+            <a:picLocks noChangeAspect="1"/>
+          </p:cNvPicPr>
+          <p:nvPr/>
+        </p:nvPicPr>
+        <p:blipFill>
+          <a:blip r:embed="rId2"/>
+          <a:stretch>
+            <a:fillRect/>
+          </a:stretch>
+        </p:blipFill>
+        <p:spPr>
+          <a:xfrm>
+            <a:off x="457200" y="1554480"/>
+            <a:ext cx="11247120" cy="4217670"/>
+          </a:xfrm>
+          <a:prstGeom prst="rect">
+            <a:avLst/>
+          </a:prstGeom>
+        </p:spPr>
+      </p:pic>
+      <p:sp>
+        <p:nvSpPr>
+          <p:cNvPr id="4" name="TextBox 3"/>
+          <p:cNvSpPr txBox="1"/>
+          <p:nvPr/>
+        </p:nvSpPr>
+        <p:spPr>
+          <a:xfrm>
+            <a:off x="457200" y="6126480"/>
+            <a:ext cx="11247120" cy="548640"/>
+          </a:xfrm>
+          <a:prstGeom prst="rect">
+            <a:avLst/>
+          </a:prstGeom>
+          <a:noFill/>
+        </p:spPr>
+        <p:txBody>
+          <a:bodyPr wrap="square">
+            <a:spAutoFit/>
+          </a:bodyPr>
+          <a:lstStyle/>
           <a:p>
             <a:pPr/>
             <a:r>
-              <a:rPr sz="1700" b="0">
-                <a:solidFill>
-                  <a:srgbClr val="222222"/>
+              <a:rPr sz="1400" b="0">
+                <a:solidFill>
+                  <a:srgbClr val="666666"/>
                 </a:solidFill>
               </a:rPr>
-              <a:t>Speed-maximizing objective under the safety constraint -&gt; most efficient among safe planners.</a:t>
-            </a:r>
-          </a:p>
-          <a:p>
-            <a:pPr/>
-            <a:r>
-              <a:rPr sz="1700" b="1">
-                <a:solidFill>
-                  <a:srgbClr val="1E7A34"/>
-                </a:solidFill>
-              </a:rPr>
-              <a:t>Runs on the real VinUni CommonRoad map + recorded GPS.</a:t>
+              <a:t>Fuses car-following (IDM) + reactive avoidance (ORCA/VO) + sampling (Frenet); fixes each one's flaw.</a:t>
             </a:r>
           </a:p>
         </p:txBody>
@@ -3650,7 +3703,7 @@
 </p:sld>
 </file>
 
-<file path=ppt/slides/slide5.xml><?xml version="1.0" encoding="utf-8"?>
+<file path=ppt/slides/slide6.xml><?xml version="1.0" encoding="utf-8"?>
 <p:sld xmlns:a="http://schemas.openxmlformats.org/drawingml/2006/main" xmlns:p="http://schemas.openxmlformats.org/presentationml/2006/main" xmlns:r="http://schemas.openxmlformats.org/officeDocument/2006/relationships">
   <p:cSld>
     <p:spTree>
@@ -4414,7 +4467,7 @@
 </p:sld>
 </file>
 
-<file path=ppt/slides/slide6.xml><?xml version="1.0" encoding="utf-8"?>
+<file path=ppt/slides/slide7.xml><?xml version="1.0" encoding="utf-8"?>
 <p:sld xmlns:a="http://schemas.openxmlformats.org/drawingml/2006/main" xmlns:p="http://schemas.openxmlformats.org/presentationml/2006/main" xmlns:r="http://schemas.openxmlformats.org/officeDocument/2006/relationships">
   <p:cSld>
     <p:spTree>

</xml_diff>

<commit_message>
Replace architecture with apex_architecture.html sections in deck
- src/render_html_sections.py: render apex_architecture.html into per-section
  PNGs via Chrome (inheritance / APEX core / results / learning-augmented),
  preserving the original dark design.
- make_pptx.py: replace the System-architecture and Method slides with the
  rendered 'inheritance (3 foundational models)' and 'APEX core (5-block
  optimizer)' sections; add a 'learning-augmented MPC (next stage)' slide.
  Full-bleed dark image slides on the blank layout. Deck is now 8 slides.

Co-Authored-By: Claude Opus 4.8 <noreply@anthropic.com>
</commit_message>
<xml_diff>
--- a/slides/Vietnam-MixedTrafficSim_APEX.pptx
+++ b/slides/Vietnam-MixedTrafficSim_APEX.pptx
@@ -15,6 +15,7 @@
     <p:sldId id="260" r:id="rId12"/>
     <p:sldId id="261" r:id="rId13"/>
     <p:sldId id="262" r:id="rId14"/>
+    <p:sldId id="263" r:id="rId15"/>
   </p:sldIdLst>
   <p:sldSz cx="12192000" cy="6858000"/>
   <p:notesSz cx="6858000" cy="9144000"/>
@@ -3399,28 +3400,50 @@
       <p:grpSpPr/>
       <p:sp>
         <p:nvSpPr>
-          <p:cNvPr id="2" name="Title 1"/>
-          <p:cNvSpPr>
-            <a:spLocks noGrp="1"/>
-          </p:cNvSpPr>
-          <p:nvPr>
-            <p:ph type="title"/>
-          </p:nvPr>
+          <p:cNvPr id="2" name="Rectangle 1"/>
+          <p:cNvSpPr/>
+          <p:nvPr/>
         </p:nvSpPr>
-        <p:spPr/>
+        <p:spPr>
+          <a:xfrm>
+            <a:off x="0" y="0"/>
+            <a:ext cx="12192000" cy="6858000"/>
+          </a:xfrm>
+          <a:prstGeom prst="rect">
+            <a:avLst/>
+          </a:prstGeom>
+          <a:solidFill>
+            <a:srgbClr val="0F1419"/>
+          </a:solidFill>
+          <a:ln>
+            <a:noFill/>
+          </a:ln>
+        </p:spPr>
+        <p:style>
+          <a:lnRef idx="1">
+            <a:schemeClr val="accent1"/>
+          </a:lnRef>
+          <a:fillRef idx="3">
+            <a:schemeClr val="accent1"/>
+          </a:fillRef>
+          <a:effectRef idx="2">
+            <a:schemeClr val="accent1"/>
+          </a:effectRef>
+          <a:fontRef idx="minor">
+            <a:schemeClr val="lt1"/>
+          </a:fontRef>
+        </p:style>
         <p:txBody>
-          <a:bodyPr/>
+          <a:bodyPr rtlCol="0" anchor="ctr"/>
           <a:lstStyle/>
           <a:p>
-            <a:r>
-              <a:t>System architecture</a:t>
-            </a:r>
+            <a:pPr algn="ctr"/>
           </a:p>
         </p:txBody>
       </p:sp>
       <p:pic>
         <p:nvPicPr>
-          <p:cNvPr id="3" name="Picture 2" descr="arch_pipeline.png"/>
+          <p:cNvPr id="3" name="Picture 2" descr="apex_arch_inherit.png"/>
           <p:cNvPicPr>
             <a:picLocks noChangeAspect="1"/>
           </p:cNvPicPr>
@@ -3434,8 +3457,8 @@
         </p:blipFill>
         <p:spPr>
           <a:xfrm>
-            <a:off x="411480" y="1325880"/>
-            <a:ext cx="11338560" cy="4960620"/>
+            <a:off x="228600" y="945955"/>
+            <a:ext cx="11734800" cy="4966090"/>
           </a:xfrm>
           <a:prstGeom prst="rect">
             <a:avLst/>
@@ -3618,28 +3641,50 @@
       <p:grpSpPr/>
       <p:sp>
         <p:nvSpPr>
-          <p:cNvPr id="2" name="Title 1"/>
-          <p:cNvSpPr>
-            <a:spLocks noGrp="1"/>
-          </p:cNvSpPr>
-          <p:nvPr>
-            <p:ph type="title"/>
-          </p:nvPr>
+          <p:cNvPr id="2" name="Rectangle 1"/>
+          <p:cNvSpPr/>
+          <p:nvPr/>
         </p:nvSpPr>
-        <p:spPr/>
+        <p:spPr>
+          <a:xfrm>
+            <a:off x="0" y="0"/>
+            <a:ext cx="12192000" cy="6858000"/>
+          </a:xfrm>
+          <a:prstGeom prst="rect">
+            <a:avLst/>
+          </a:prstGeom>
+          <a:solidFill>
+            <a:srgbClr val="0F1419"/>
+          </a:solidFill>
+          <a:ln>
+            <a:noFill/>
+          </a:ln>
+        </p:spPr>
+        <p:style>
+          <a:lnRef idx="1">
+            <a:schemeClr val="accent1"/>
+          </a:lnRef>
+          <a:fillRef idx="3">
+            <a:schemeClr val="accent1"/>
+          </a:fillRef>
+          <a:effectRef idx="2">
+            <a:schemeClr val="accent1"/>
+          </a:effectRef>
+          <a:fontRef idx="minor">
+            <a:schemeClr val="lt1"/>
+          </a:fontRef>
+        </p:style>
         <p:txBody>
-          <a:bodyPr/>
+          <a:bodyPr rtlCol="0" anchor="ctr"/>
           <a:lstStyle/>
           <a:p>
-            <a:r>
-              <a:t>APEX - predictive risk-aware planner</a:t>
-            </a:r>
+            <a:pPr algn="ctr"/>
           </a:p>
         </p:txBody>
       </p:sp>
       <p:pic>
         <p:nvPicPr>
-          <p:cNvPr id="3" name="Picture 2" descr="apex_model.png"/>
+          <p:cNvPr id="3" name="Picture 2" descr="apex_arch_core.png"/>
           <p:cNvPicPr>
             <a:picLocks noChangeAspect="1"/>
           </p:cNvPicPr>
@@ -3653,48 +3698,14 @@
         </p:blipFill>
         <p:spPr>
           <a:xfrm>
-            <a:off x="457200" y="1554480"/>
-            <a:ext cx="11247120" cy="4217670"/>
+            <a:off x="228600" y="1121139"/>
+            <a:ext cx="11734800" cy="4615722"/>
           </a:xfrm>
           <a:prstGeom prst="rect">
             <a:avLst/>
           </a:prstGeom>
         </p:spPr>
       </p:pic>
-      <p:sp>
-        <p:nvSpPr>
-          <p:cNvPr id="4" name="TextBox 3"/>
-          <p:cNvSpPr txBox="1"/>
-          <p:nvPr/>
-        </p:nvSpPr>
-        <p:spPr>
-          <a:xfrm>
-            <a:off x="457200" y="6126480"/>
-            <a:ext cx="11247120" cy="548640"/>
-          </a:xfrm>
-          <a:prstGeom prst="rect">
-            <a:avLst/>
-          </a:prstGeom>
-          <a:noFill/>
-        </p:spPr>
-        <p:txBody>
-          <a:bodyPr wrap="square">
-            <a:spAutoFit/>
-          </a:bodyPr>
-          <a:lstStyle/>
-          <a:p>
-            <a:pPr/>
-            <a:r>
-              <a:rPr sz="1400" b="0">
-                <a:solidFill>
-                  <a:srgbClr val="666666"/>
-                </a:solidFill>
-              </a:rPr>
-              <a:t>Fuses car-following (IDM) + reactive avoidance (ORCA/VO) + sampling (Frenet); fixes each one's flaw.</a:t>
-            </a:r>
-          </a:p>
-        </p:txBody>
-      </p:sp>
     </p:spTree>
   </p:cSld>
   <p:clrMapOvr>
@@ -4479,6 +4490,91 @@
       <p:grpSpPr/>
       <p:sp>
         <p:nvSpPr>
+          <p:cNvPr id="2" name="Rectangle 1"/>
+          <p:cNvSpPr/>
+          <p:nvPr/>
+        </p:nvSpPr>
+        <p:spPr>
+          <a:xfrm>
+            <a:off x="0" y="0"/>
+            <a:ext cx="12192000" cy="6858000"/>
+          </a:xfrm>
+          <a:prstGeom prst="rect">
+            <a:avLst/>
+          </a:prstGeom>
+          <a:solidFill>
+            <a:srgbClr val="0F1419"/>
+          </a:solidFill>
+          <a:ln>
+            <a:noFill/>
+          </a:ln>
+        </p:spPr>
+        <p:style>
+          <a:lnRef idx="1">
+            <a:schemeClr val="accent1"/>
+          </a:lnRef>
+          <a:fillRef idx="3">
+            <a:schemeClr val="accent1"/>
+          </a:fillRef>
+          <a:effectRef idx="2">
+            <a:schemeClr val="accent1"/>
+          </a:effectRef>
+          <a:fontRef idx="minor">
+            <a:schemeClr val="lt1"/>
+          </a:fontRef>
+        </p:style>
+        <p:txBody>
+          <a:bodyPr rtlCol="0" anchor="ctr"/>
+          <a:lstStyle/>
+          <a:p>
+            <a:pPr algn="ctr"/>
+          </a:p>
+        </p:txBody>
+      </p:sp>
+      <p:pic>
+        <p:nvPicPr>
+          <p:cNvPr id="3" name="Picture 2" descr="apex_arch_learn.png"/>
+          <p:cNvPicPr>
+            <a:picLocks noChangeAspect="1"/>
+          </p:cNvPicPr>
+          <p:nvPr/>
+        </p:nvPicPr>
+        <p:blipFill>
+          <a:blip r:embed="rId2"/>
+          <a:stretch>
+            <a:fillRect/>
+          </a:stretch>
+        </p:blipFill>
+        <p:spPr>
+          <a:xfrm>
+            <a:off x="1360965" y="228600"/>
+            <a:ext cx="9470070" cy="6400800"/>
+          </a:xfrm>
+          <a:prstGeom prst="rect">
+            <a:avLst/>
+          </a:prstGeom>
+        </p:spPr>
+      </p:pic>
+    </p:spTree>
+  </p:cSld>
+  <p:clrMapOvr>
+    <a:masterClrMapping/>
+  </p:clrMapOvr>
+</p:sld>
+</file>
+
+<file path=ppt/slides/slide8.xml><?xml version="1.0" encoding="utf-8"?>
+<p:sld xmlns:a="http://schemas.openxmlformats.org/drawingml/2006/main" xmlns:p="http://schemas.openxmlformats.org/presentationml/2006/main" xmlns:r="http://schemas.openxmlformats.org/officeDocument/2006/relationships">
+  <p:cSld>
+    <p:spTree>
+      <p:nvGrpSpPr>
+        <p:cNvPr id="1" name=""/>
+        <p:cNvGrpSpPr/>
+        <p:nvPr/>
+      </p:nvGrpSpPr>
+      <p:grpSpPr/>
+      <p:sp>
+        <p:nvSpPr>
           <p:cNvPr id="2" name="Title 1"/>
           <p:cNvSpPr>
             <a:spLocks noGrp="1"/>

</xml_diff>

<commit_message>
Adopt APEX backronym from apex_definition.md (Anticipatory Predictive EXclusion)
- apex_architecture.html: title -> 'Anticipatory Predictive EXclusion planner';
  sub spells out A/P/EX with the hard-exclusion mechanism (collision-free by
  construction).
- make_pptx.py: cover subtitle spells out the acronym.
- re-rendered architecture section images + rebuilt deck.

Co-Authored-By: Claude Opus 4.8 <noreply@anthropic.com>
</commit_message>
<xml_diff>
--- a/slides/Vietnam-MixedTrafficSim_APEX.pptx
+++ b/slides/Vietnam-MixedTrafficSim_APEX.pptx
@@ -3155,12 +3155,12 @@
           <a:lstStyle/>
           <a:p>
             <a:r>
-              <a:rPr sz="2000" b="0">
+              <a:rPr sz="1800" b="0">
                 <a:solidFill>
                   <a:srgbClr val="222222"/>
                 </a:solidFill>
               </a:rPr>
-              <a:t>APEX: a predictive risk-aware planner for Vietnamese mixed traffic</a:t>
+              <a:t>APEX = Anticipatory · Predictive · EXclusion — a safety-constrained planner for Vietnamese mixed traffic</a:t>
             </a:r>
             <a:endParaRPr lang="en-US"/>
           </a:p>

</xml_diff>

<commit_message>
Add % improvement bar charts to deck
- src/make_charts.py: bench_bars.png (collision rate + R_T per planner) and
  apex_improvement.png (APEX % improvement: collisions -100% vs baseline &
  moto-aware; 23% faster than conservative; 9% faster than IDM).
- make_pptx.py: add both charts as slides after the results table.

Co-Authored-By: Claude Opus 4.8 <noreply@anthropic.com>
</commit_message>
<xml_diff>
--- a/slides/Vietnam-MixedTrafficSim_APEX.pptx
+++ b/slides/Vietnam-MixedTrafficSim_APEX.pptx
@@ -16,6 +16,8 @@
     <p:sldId id="261" r:id="rId13"/>
     <p:sldId id="262" r:id="rId14"/>
     <p:sldId id="263" r:id="rId15"/>
+    <p:sldId id="264" r:id="rId16"/>
+    <p:sldId id="265" r:id="rId17"/>
   </p:sldIdLst>
   <p:sldSz cx="12192000" cy="6858000"/>
   <p:notesSz cx="6858000" cy="9144000"/>
@@ -3205,6 +3207,116 @@
         <p14:creationId xmlns:p14="http://schemas.microsoft.com/office/powerpoint/2010/main" val="1370658256"/>
       </p:ext>
     </p:extLst>
+  </p:cSld>
+  <p:clrMapOvr>
+    <a:masterClrMapping/>
+  </p:clrMapOvr>
+</p:sld>
+</file>
+
+<file path=ppt/slides/slide10.xml><?xml version="1.0" encoding="utf-8"?>
+<p:sld xmlns:a="http://schemas.openxmlformats.org/drawingml/2006/main" xmlns:p="http://schemas.openxmlformats.org/presentationml/2006/main" xmlns:r="http://schemas.openxmlformats.org/officeDocument/2006/relationships">
+  <p:cSld>
+    <p:spTree>
+      <p:nvGrpSpPr>
+        <p:cNvPr id="1" name=""/>
+        <p:cNvGrpSpPr/>
+        <p:nvPr/>
+      </p:nvGrpSpPr>
+      <p:grpSpPr/>
+      <p:sp>
+        <p:nvSpPr>
+          <p:cNvPr id="2" name="Title 1"/>
+          <p:cNvSpPr>
+            <a:spLocks noGrp="1"/>
+          </p:cNvSpPr>
+          <p:nvPr>
+            <p:ph type="title"/>
+          </p:nvPr>
+        </p:nvSpPr>
+        <p:spPr/>
+        <p:txBody>
+          <a:bodyPr/>
+          <a:lstStyle/>
+          <a:p>
+            <a:r>
+              <a:t>Live demo &amp; next steps</a:t>
+            </a:r>
+          </a:p>
+        </p:txBody>
+      </p:sp>
+      <p:sp>
+        <p:nvSpPr>
+          <p:cNvPr id="3" name="Content Placeholder 2"/>
+          <p:cNvSpPr>
+            <a:spLocks noGrp="1"/>
+          </p:cNvSpPr>
+          <p:nvPr>
+            <p:ph idx="1"/>
+          </p:nvPr>
+        </p:nvSpPr>
+        <p:spPr/>
+        <p:txBody>
+          <a:bodyPr wrap="square"/>
+          <a:lstStyle/>
+          <a:p>
+            <a:pPr/>
+            <a:r>
+              <a:rPr sz="1800" b="0">
+                <a:solidFill>
+                  <a:srgbClr val="222222"/>
+                </a:solidFill>
+              </a:rPr>
+              <a:t>6 scenario videos (4 panels: baseline | ORCA/VO | moto-aware | APEX) - others collide, APEX stays safe:</a:t>
+            </a:r>
+          </a:p>
+          <a:p>
+            <a:pPr lvl="1"/>
+            <a:r>
+              <a:rPr sz="1600" b="0">
+                <a:solidFill>
+                  <a:srgbClr val="666666"/>
+                </a:solidFill>
+              </a:rPr>
+              <a:t>cut-in, junction crossing, shoulder merge, multi-lane weave, two- and three-motorcycle scenes.</a:t>
+            </a:r>
+          </a:p>
+          <a:p>
+            <a:pPr/>
+            <a:r>
+              <a:rPr sz="1800" b="0">
+                <a:solidFill>
+                  <a:srgbClr val="222222"/>
+                </a:solidFill>
+              </a:rPr>
+              <a:t>Aligns with the CommonRoad 2024 competition (winning Frenet paradigm; we add prediction it lacked).</a:t>
+            </a:r>
+          </a:p>
+          <a:p>
+            <a:pPr/>
+            <a:r>
+              <a:rPr sz="1600" b="0">
+                <a:solidFill>
+                  <a:srgbClr val="B21F1F"/>
+                </a:solidFill>
+              </a:rPr>
+              <a:t>Honest limits (PR2 Sec 7): motorcycle-behaviour calibration in progress; YOLO range is approximate.</a:t>
+            </a:r>
+          </a:p>
+          <a:p>
+            <a:pPr/>
+            <a:r>
+              <a:rPr sz="1800" b="1">
+                <a:solidFill>
+                  <a:srgbClr val="1E7A34"/>
+                </a:solidFill>
+              </a:rPr>
+              <a:t>Next: calibrate motorcycle behaviour from 200 h moto + 5 car-trip data; CARLA 3D validation.</a:t>
+            </a:r>
+          </a:p>
+        </p:txBody>
+      </p:sp>
+    </p:spTree>
   </p:cSld>
   <p:clrMapOvr>
     <a:masterClrMapping/>
@@ -4503,6 +4615,176 @@
             <a:avLst/>
           </a:prstGeom>
           <a:solidFill>
+            <a:srgbClr val="FFFFFF"/>
+          </a:solidFill>
+          <a:ln>
+            <a:noFill/>
+          </a:ln>
+        </p:spPr>
+        <p:style>
+          <a:lnRef idx="1">
+            <a:schemeClr val="accent1"/>
+          </a:lnRef>
+          <a:fillRef idx="3">
+            <a:schemeClr val="accent1"/>
+          </a:fillRef>
+          <a:effectRef idx="2">
+            <a:schemeClr val="accent1"/>
+          </a:effectRef>
+          <a:fontRef idx="minor">
+            <a:schemeClr val="lt1"/>
+          </a:fontRef>
+        </p:style>
+        <p:txBody>
+          <a:bodyPr rtlCol="0" anchor="ctr"/>
+          <a:lstStyle/>
+          <a:p>
+            <a:pPr algn="ctr"/>
+          </a:p>
+        </p:txBody>
+      </p:sp>
+      <p:pic>
+        <p:nvPicPr>
+          <p:cNvPr id="3" name="Picture 2" descr="bench_bars.png"/>
+          <p:cNvPicPr>
+            <a:picLocks noChangeAspect="1"/>
+          </p:cNvPicPr>
+          <p:nvPr/>
+        </p:nvPicPr>
+        <p:blipFill>
+          <a:blip r:embed="rId2"/>
+          <a:stretch>
+            <a:fillRect/>
+          </a:stretch>
+        </p:blipFill>
+        <p:spPr>
+          <a:xfrm>
+            <a:off x="228600" y="1134979"/>
+            <a:ext cx="11734800" cy="4588042"/>
+          </a:xfrm>
+          <a:prstGeom prst="rect">
+            <a:avLst/>
+          </a:prstGeom>
+        </p:spPr>
+      </p:pic>
+    </p:spTree>
+  </p:cSld>
+  <p:clrMapOvr>
+    <a:masterClrMapping/>
+  </p:clrMapOvr>
+</p:sld>
+</file>
+
+<file path=ppt/slides/slide8.xml><?xml version="1.0" encoding="utf-8"?>
+<p:sld xmlns:a="http://schemas.openxmlformats.org/drawingml/2006/main" xmlns:p="http://schemas.openxmlformats.org/presentationml/2006/main" xmlns:r="http://schemas.openxmlformats.org/officeDocument/2006/relationships">
+  <p:cSld>
+    <p:spTree>
+      <p:nvGrpSpPr>
+        <p:cNvPr id="1" name=""/>
+        <p:cNvGrpSpPr/>
+        <p:nvPr/>
+      </p:nvGrpSpPr>
+      <p:grpSpPr/>
+      <p:sp>
+        <p:nvSpPr>
+          <p:cNvPr id="2" name="Rectangle 1"/>
+          <p:cNvSpPr/>
+          <p:nvPr/>
+        </p:nvSpPr>
+        <p:spPr>
+          <a:xfrm>
+            <a:off x="0" y="0"/>
+            <a:ext cx="12192000" cy="6858000"/>
+          </a:xfrm>
+          <a:prstGeom prst="rect">
+            <a:avLst/>
+          </a:prstGeom>
+          <a:solidFill>
+            <a:srgbClr val="FFFFFF"/>
+          </a:solidFill>
+          <a:ln>
+            <a:noFill/>
+          </a:ln>
+        </p:spPr>
+        <p:style>
+          <a:lnRef idx="1">
+            <a:schemeClr val="accent1"/>
+          </a:lnRef>
+          <a:fillRef idx="3">
+            <a:schemeClr val="accent1"/>
+          </a:fillRef>
+          <a:effectRef idx="2">
+            <a:schemeClr val="accent1"/>
+          </a:effectRef>
+          <a:fontRef idx="minor">
+            <a:schemeClr val="lt1"/>
+          </a:fontRef>
+        </p:style>
+        <p:txBody>
+          <a:bodyPr rtlCol="0" anchor="ctr"/>
+          <a:lstStyle/>
+          <a:p>
+            <a:pPr algn="ctr"/>
+          </a:p>
+        </p:txBody>
+      </p:sp>
+      <p:pic>
+        <p:nvPicPr>
+          <p:cNvPr id="3" name="Picture 2" descr="apex_improvement.png"/>
+          <p:cNvPicPr>
+            <a:picLocks noChangeAspect="1"/>
+          </p:cNvPicPr>
+          <p:nvPr/>
+        </p:nvPicPr>
+        <p:blipFill>
+          <a:blip r:embed="rId2"/>
+          <a:stretch>
+            <a:fillRect/>
+          </a:stretch>
+        </p:blipFill>
+        <p:spPr>
+          <a:xfrm>
+            <a:off x="228600" y="1223210"/>
+            <a:ext cx="11734800" cy="4411579"/>
+          </a:xfrm>
+          <a:prstGeom prst="rect">
+            <a:avLst/>
+          </a:prstGeom>
+        </p:spPr>
+      </p:pic>
+    </p:spTree>
+  </p:cSld>
+  <p:clrMapOvr>
+    <a:masterClrMapping/>
+  </p:clrMapOvr>
+</p:sld>
+</file>
+
+<file path=ppt/slides/slide9.xml><?xml version="1.0" encoding="utf-8"?>
+<p:sld xmlns:a="http://schemas.openxmlformats.org/drawingml/2006/main" xmlns:p="http://schemas.openxmlformats.org/presentationml/2006/main" xmlns:r="http://schemas.openxmlformats.org/officeDocument/2006/relationships">
+  <p:cSld>
+    <p:spTree>
+      <p:nvGrpSpPr>
+        <p:cNvPr id="1" name=""/>
+        <p:cNvGrpSpPr/>
+        <p:nvPr/>
+      </p:nvGrpSpPr>
+      <p:grpSpPr/>
+      <p:sp>
+        <p:nvSpPr>
+          <p:cNvPr id="2" name="Rectangle 1"/>
+          <p:cNvSpPr/>
+          <p:nvPr/>
+        </p:nvSpPr>
+        <p:spPr>
+          <a:xfrm>
+            <a:off x="0" y="0"/>
+            <a:ext cx="12192000" cy="6858000"/>
+          </a:xfrm>
+          <a:prstGeom prst="rect">
+            <a:avLst/>
+          </a:prstGeom>
+          <a:solidFill>
             <a:srgbClr val="0F1419"/>
           </a:solidFill>
           <a:ln>
@@ -4555,116 +4837,6 @@
           </a:prstGeom>
         </p:spPr>
       </p:pic>
-    </p:spTree>
-  </p:cSld>
-  <p:clrMapOvr>
-    <a:masterClrMapping/>
-  </p:clrMapOvr>
-</p:sld>
-</file>
-
-<file path=ppt/slides/slide8.xml><?xml version="1.0" encoding="utf-8"?>
-<p:sld xmlns:a="http://schemas.openxmlformats.org/drawingml/2006/main" xmlns:p="http://schemas.openxmlformats.org/presentationml/2006/main" xmlns:r="http://schemas.openxmlformats.org/officeDocument/2006/relationships">
-  <p:cSld>
-    <p:spTree>
-      <p:nvGrpSpPr>
-        <p:cNvPr id="1" name=""/>
-        <p:cNvGrpSpPr/>
-        <p:nvPr/>
-      </p:nvGrpSpPr>
-      <p:grpSpPr/>
-      <p:sp>
-        <p:nvSpPr>
-          <p:cNvPr id="2" name="Title 1"/>
-          <p:cNvSpPr>
-            <a:spLocks noGrp="1"/>
-          </p:cNvSpPr>
-          <p:nvPr>
-            <p:ph type="title"/>
-          </p:nvPr>
-        </p:nvSpPr>
-        <p:spPr/>
-        <p:txBody>
-          <a:bodyPr/>
-          <a:lstStyle/>
-          <a:p>
-            <a:r>
-              <a:t>Live demo &amp; next steps</a:t>
-            </a:r>
-          </a:p>
-        </p:txBody>
-      </p:sp>
-      <p:sp>
-        <p:nvSpPr>
-          <p:cNvPr id="3" name="Content Placeholder 2"/>
-          <p:cNvSpPr>
-            <a:spLocks noGrp="1"/>
-          </p:cNvSpPr>
-          <p:nvPr>
-            <p:ph idx="1"/>
-          </p:nvPr>
-        </p:nvSpPr>
-        <p:spPr/>
-        <p:txBody>
-          <a:bodyPr wrap="square"/>
-          <a:lstStyle/>
-          <a:p>
-            <a:pPr/>
-            <a:r>
-              <a:rPr sz="1800" b="0">
-                <a:solidFill>
-                  <a:srgbClr val="222222"/>
-                </a:solidFill>
-              </a:rPr>
-              <a:t>6 scenario videos (4 panels: baseline | ORCA/VO | moto-aware | APEX) - others collide, APEX stays safe:</a:t>
-            </a:r>
-          </a:p>
-          <a:p>
-            <a:pPr lvl="1"/>
-            <a:r>
-              <a:rPr sz="1600" b="0">
-                <a:solidFill>
-                  <a:srgbClr val="666666"/>
-                </a:solidFill>
-              </a:rPr>
-              <a:t>cut-in, junction crossing, shoulder merge, multi-lane weave, two- and three-motorcycle scenes.</a:t>
-            </a:r>
-          </a:p>
-          <a:p>
-            <a:pPr/>
-            <a:r>
-              <a:rPr sz="1800" b="0">
-                <a:solidFill>
-                  <a:srgbClr val="222222"/>
-                </a:solidFill>
-              </a:rPr>
-              <a:t>Aligns with the CommonRoad 2024 competition (winning Frenet paradigm; we add prediction it lacked).</a:t>
-            </a:r>
-          </a:p>
-          <a:p>
-            <a:pPr/>
-            <a:r>
-              <a:rPr sz="1600" b="0">
-                <a:solidFill>
-                  <a:srgbClr val="B21F1F"/>
-                </a:solidFill>
-              </a:rPr>
-              <a:t>Honest limits (PR2 Sec 7): motorcycle-behaviour calibration in progress; YOLO range is approximate.</a:t>
-            </a:r>
-          </a:p>
-          <a:p>
-            <a:pPr/>
-            <a:r>
-              <a:rPr sz="1800" b="1">
-                <a:solidFill>
-                  <a:srgbClr val="1E7A34"/>
-                </a:solidFill>
-              </a:rPr>
-              <a:t>Next: calibrate motorcycle behaviour from 200 h moto + 5 car-trip data; CARLA 3D validation.</a:t>
-            </a:r>
-          </a:p>
-        </p:txBody>
-      </p:sp>
     </p:spTree>
   </p:cSld>
   <p:clrMapOvr>

</xml_diff>

<commit_message>
Recolor architecture diagrams to the white/red/blue VinUni theme
- render_html_sections.py: LIGHT mode maps the dark apex_architecture.html
  palette + category chips + surfaces to a white background with VinUni
  red/blue/green accents (so the architecture slides match the template).
- make_pptx.py: architecture image slides now use a white background.

Co-Authored-By: Claude Opus 4.8 <noreply@anthropic.com>
</commit_message>
<xml_diff>
--- a/slides/Vietnam-MixedTrafficSim_APEX.pptx
+++ b/slides/Vietnam-MixedTrafficSim_APEX.pptx
@@ -3525,7 +3525,7 @@
             <a:avLst/>
           </a:prstGeom>
           <a:solidFill>
-            <a:srgbClr val="0F1419"/>
+            <a:srgbClr val="FFFFFF"/>
           </a:solidFill>
           <a:ln>
             <a:noFill/>
@@ -3569,8 +3569,8 @@
         </p:blipFill>
         <p:spPr>
           <a:xfrm>
-            <a:off x="228600" y="945955"/>
-            <a:ext cx="11734800" cy="4966090"/>
+            <a:off x="228600" y="948494"/>
+            <a:ext cx="11734800" cy="4961012"/>
           </a:xfrm>
           <a:prstGeom prst="rect">
             <a:avLst/>
@@ -3766,7 +3766,7 @@
             <a:avLst/>
           </a:prstGeom>
           <a:solidFill>
-            <a:srgbClr val="0F1419"/>
+            <a:srgbClr val="FFFFFF"/>
           </a:solidFill>
           <a:ln>
             <a:noFill/>
@@ -3810,8 +3810,8 @@
         </p:blipFill>
         <p:spPr>
           <a:xfrm>
-            <a:off x="228600" y="1121139"/>
-            <a:ext cx="11734800" cy="4615722"/>
+            <a:off x="228600" y="1123678"/>
+            <a:ext cx="11734800" cy="4610644"/>
           </a:xfrm>
           <a:prstGeom prst="rect">
             <a:avLst/>
@@ -4785,7 +4785,7 @@
             <a:avLst/>
           </a:prstGeom>
           <a:solidFill>
-            <a:srgbClr val="0F1419"/>
+            <a:srgbClr val="FFFFFF"/>
           </a:solidFill>
           <a:ln>
             <a:noFill/>
@@ -4829,8 +4829,8 @@
         </p:blipFill>
         <p:spPr>
           <a:xfrm>
-            <a:off x="1360965" y="228600"/>
-            <a:ext cx="9470070" cy="6400800"/>
+            <a:off x="1357932" y="228600"/>
+            <a:ext cx="9476136" cy="6400800"/>
           </a:xfrm>
           <a:prstGeom prst="rect">
             <a:avLst/>

</xml_diff>